<commit_message>
Homogeneiza las presentaciones de reunión
</commit_message>
<xml_diff>
--- a/assets/presentations/2025-11-30-despierta-mi-vida.pptx
+++ b/assets/presentations/2025-11-30-despierta-mi-vida.pptx
@@ -2,15 +2,15 @@
 <file path=ppt/presentation.xml><?xml version="1.0" encoding="utf-8"?>
 <p:presentation xmlns:p="http://schemas.openxmlformats.org/presentationml/2006/main">
   <p:sldMasterIdLst>
-    <p:sldMasterId xmlns:r="http://schemas.openxmlformats.org/officeDocument/2006/relationships" id="2147483648" r:id="Rfff90ee6fe314a0f"/>
+    <p:sldMasterId xmlns:r="http://schemas.openxmlformats.org/officeDocument/2006/relationships" id="2147483648" r:id="R3b55c446847b404c"/>
   </p:sldMasterIdLst>
   <p:notesMasterIdLst>
-    <p:notesMasterId xmlns:r="http://schemas.openxmlformats.org/officeDocument/2006/relationships" r:id="Ra4b5f8a9de1f42e9"/>
+    <p:notesMasterId xmlns:r="http://schemas.openxmlformats.org/officeDocument/2006/relationships" r:id="Re71614c3b7b54202"/>
   </p:notesMasterIdLst>
   <p:sldIdLst>
-    <p:sldId xmlns:r="http://schemas.openxmlformats.org/officeDocument/2006/relationships" id="256" r:id="R46479f067e1941ed"/>
-    <p:sldId xmlns:r="http://schemas.openxmlformats.org/officeDocument/2006/relationships" id="257" r:id="R373053bc32af461f"/>
-    <p:sldId xmlns:r="http://schemas.openxmlformats.org/officeDocument/2006/relationships" id="258" r:id="Rad2fc251cd1f4232"/>
+    <p:sldId xmlns:r="http://schemas.openxmlformats.org/officeDocument/2006/relationships" id="256" r:id="R2e665a60202e4b15"/>
+    <p:sldId xmlns:r="http://schemas.openxmlformats.org/officeDocument/2006/relationships" id="257" r:id="Rc70c19e939714f43"/>
+    <p:sldId xmlns:r="http://schemas.openxmlformats.org/officeDocument/2006/relationships" id="258" r:id="R08a8a6b892dd4c73"/>
   </p:sldIdLst>
   <p:sldSz cx="12192000" cy="6858000"/>
   <p:notesSz cx="6858000" cy="9144000"/>
@@ -787,7 +787,7 @@
   </p:cSld>
   <p:clrMap bg1="lt1" tx1="dk1" bg2="lt2" tx2="dk2" accent1="accent1" accent2="accent2" accent3="accent3" accent4="accent4" accent5="accent5" accent6="accent6" hlink="hlink" folHlink="folHlink"/>
   <p:sldLayoutIdLst>
-    <p:sldLayoutId xmlns:r="http://schemas.openxmlformats.org/officeDocument/2006/relationships" id="2147483649" r:id="R5c9436a664bd4f0c"/>
+    <p:sldLayoutId xmlns:r="http://schemas.openxmlformats.org/officeDocument/2006/relationships" id="2147483649" r:id="R8c32a3b01f8b415f"/>
   </p:sldLayoutIdLst>
   <p:txStyles>
     <p:titleStyle>
@@ -1335,7 +1335,7 @@
           <p:nvPr/>
         </p:nvPicPr>
         <p:blipFill>
-          <a:blip xmlns:r="http://schemas.openxmlformats.org/officeDocument/2006/relationships" xmlns:a="http://schemas.openxmlformats.org/drawingml/2006/main" r:embed="R3e390ec2fbdb4c33"/>
+          <a:blip xmlns:r="http://schemas.openxmlformats.org/officeDocument/2006/relationships" xmlns:a="http://schemas.openxmlformats.org/drawingml/2006/main" r:embed="Rf001b2f17c424086"/>
           <a:srcRect xmlns:a="http://schemas.openxmlformats.org/drawingml/2006/main" l="0" t="27" r="0" b="27"/>
           <a:stretch xmlns:a="http://schemas.openxmlformats.org/drawingml/2006/main">
             <a:fillRect l="0" t="0" r="0" b="0"/>
@@ -1521,7 +1521,7 @@
         </p:nvSpPr>
         <p:spPr>
           <a:xfrm xmlns:a="http://schemas.openxmlformats.org/drawingml/2006/main">
-            <a:off x="3943350" y="1381125"/>
+            <a:off x="762000" y="1381125"/>
             <a:ext cx="4305300" cy="1581150"/>
           </a:xfrm>
           <a:prstGeom xmlns:a="http://schemas.openxmlformats.org/drawingml/2006/main" prst="roundRect">
@@ -1553,7 +1553,7 @@
         </p:nvSpPr>
         <p:spPr>
           <a:xfrm xmlns:a="http://schemas.openxmlformats.org/drawingml/2006/main">
-            <a:off x="4514850" y="1552575"/>
+            <a:off x="1333500" y="1552575"/>
             <a:ext cx="3162300" cy="742950"/>
           </a:xfrm>
           <a:prstGeom xmlns:a="http://schemas.openxmlformats.org/drawingml/2006/main" prst="rect">
@@ -1571,14 +1571,21 @@
             <a:pPr algn="ctr">
               <a:buNone/>
               <a:defRPr sz="1875" b="1">
-                <a:solidFill>
-                  <a:srgbClr val="FFFFFF"/>
+                <a:ln w="0">
+                  <a:noFill/>
+                  <a:prstDash val="solid"/>
+                </a:ln>
+                <a:solidFill>
+                  <a:srgbClr val="F5E7C3"/>
                 </a:solidFill>
               </a:defRPr>
             </a:pPr>
             <a:r>
               <a:rPr sz="1875">
-                <a:ln w="0"/>
+                <a:ln w="0">
+                  <a:noFill/>
+                  <a:prstDash val="solid"/>
+                </a:ln>
                 <a:solidFill>
                   <a:srgbClr val="F5E7C3"/>
                 </a:solidFill>
@@ -1597,14 +1604,21 @@
             <a:pPr algn="ctr">
               <a:buNone/>
               <a:defRPr sz="1875" b="1">
-                <a:solidFill>
-                  <a:srgbClr val="FFFFFF"/>
+                <a:ln w="0">
+                  <a:noFill/>
+                  <a:prstDash val="solid"/>
+                </a:ln>
+                <a:solidFill>
+                  <a:srgbClr val="F5E7C3"/>
                 </a:solidFill>
               </a:defRPr>
             </a:pPr>
             <a:r>
               <a:rPr sz="1875">
-                <a:ln w="0"/>
+                <a:ln w="0">
+                  <a:noFill/>
+                  <a:prstDash val="solid"/>
+                </a:ln>
                 <a:solidFill>
                   <a:srgbClr val="F5E7C3"/>
                 </a:solidFill>
@@ -1637,7 +1651,7 @@
         </p:nvSpPr>
         <p:spPr>
           <a:xfrm xmlns:a="http://schemas.openxmlformats.org/drawingml/2006/main">
-            <a:off x="4305300" y="2200275"/>
+            <a:off x="1123950" y="2200275"/>
             <a:ext cx="3848100" cy="457200"/>
           </a:xfrm>
           <a:prstGeom xmlns:a="http://schemas.openxmlformats.org/drawingml/2006/main" prst="rect">
@@ -1655,6 +1669,10 @@
             <a:pPr>
               <a:buNone/>
               <a:defRPr sz="1200" b="0">
+                <a:ln w="0">
+                  <a:noFill/>
+                  <a:prstDash val="solid"/>
+                </a:ln>
                 <a:solidFill>
                   <a:srgbClr val="FFFFFF"/>
                 </a:solidFill>
@@ -1662,7 +1680,10 @@
             </a:pPr>
             <a:r>
               <a:rPr sz="1200">
-                <a:ln w="0"/>
+                <a:ln w="0">
+                  <a:noFill/>
+                  <a:prstDash val="solid"/>
+                </a:ln>
                 <a:solidFill>
                   <a:srgbClr val="FFFFFF"/>
                 </a:solidFill>
@@ -1681,6 +1702,10 @@
             <a:pPr>
               <a:buNone/>
               <a:defRPr sz="1200" b="0">
+                <a:ln w="0">
+                  <a:noFill/>
+                  <a:prstDash val="solid"/>
+                </a:ln>
                 <a:solidFill>
                   <a:srgbClr val="FFFFFF"/>
                 </a:solidFill>
@@ -1688,7 +1713,10 @@
             </a:pPr>
             <a:r>
               <a:rPr sz="1200">
-                <a:ln w="0"/>
+                <a:ln w="0">
+                  <a:noFill/>
+                  <a:prstDash val="solid"/>
+                </a:ln>
                 <a:solidFill>
                   <a:srgbClr val="FFFFFF"/>
                 </a:solidFill>

</xml_diff>